<commit_message>
Deck: show the dashboard instead of describing it
Slide 16 was bullets about the dashboard with no dashboard. It now carries a
fresh 1600x900 capture of the live page -- native 16:9, so it drops onto the
slide without letterboxing -- with the key points in a side panel and the URL
underneath.

Also verified the whole deck programmatically, since a generated deck is easy to
get subtly wrong and hard to eyeball: no text shape overflows its box, no bullet
block collides with the callout beneath it (tightest gap 30pt), every slide has
speaker notes.
</commit_message>
<xml_diff>
--- a/deliverables/DevSecOps_Secure_Pipeline.pptx
+++ b/deliverables/DevSecOps_Secure_Pipeline.pptx
@@ -1013,7 +1013,7 @@
           <a:lstStyle/>
           <a:p>
             <a:r>
-              <a:t>Open this live during the presentation if you have network. Click one gate and let the inspector panel appear — it shows what that gate checks, how many runs it has blocked, and the exact command to reproduce it locally. That interactivity is what makes it feel like a product rather than a status page.</a:t>
+              <a:t>Open this live rather than describing it -- network permitting. Click one gate and let the inspector panel appear: it shows what that gate checks, how many runs it has blocked, and the exact command to reproduce it locally. Then click a run row and let it expand to show every job with its duration and a link to its log. That interactivity is what makes this feel like a product rather than a status page. If the network fails, the bullets on the right still carry the message.</a:t>
             </a:r>
           </a:p>
         </p:txBody>
@@ -7202,16 +7202,40 @@
           </a:p>
         </p:txBody>
       </p:sp>
-      <p:sp>
-        <p:nvSpPr>
-          <p:cNvPr id="5" name="TextBox 4"/>
+      <p:pic>
+        <p:nvPicPr>
+          <p:cNvPr id="5" name="Picture 4" descr="dashboard.png"/>
+          <p:cNvPicPr>
+            <a:picLocks noChangeAspect="1"/>
+          </p:cNvPicPr>
+          <p:nvPr/>
+        </p:nvPicPr>
+        <p:blipFill>
+          <a:blip r:embed="rId2"/>
+          <a:stretch>
+            <a:fillRect/>
+          </a:stretch>
+        </p:blipFill>
+        <p:spPr>
+          <a:xfrm>
+            <a:off x="566928" y="1627632"/>
+            <a:ext cx="7498079" cy="4217669"/>
+          </a:xfrm>
+          <a:prstGeom prst="rect">
+            <a:avLst/>
+          </a:prstGeom>
+        </p:spPr>
+      </p:pic>
+      <p:sp>
+        <p:nvSpPr>
+          <p:cNvPr id="6" name="TextBox 5"/>
           <p:cNvSpPr txBox="1"/>
           <p:nvPr/>
         </p:nvSpPr>
         <p:spPr>
           <a:xfrm>
-            <a:off x="685800" y="1691640"/>
-            <a:ext cx="10789920" cy="4206240"/>
+            <a:off x="566928" y="6144768"/>
+            <a:ext cx="7498079" cy="365760"/>
           </a:xfrm>
           <a:prstGeom prst="rect">
             <a:avLst/>
@@ -7224,165 +7248,36 @@
           </a:bodyPr>
           <a:lstStyle/>
           <a:p>
-            <a:pPr algn="l">
-              <a:lnSpc>
-                <a:spcPct val="115000"/>
-              </a:lnSpc>
-              <a:spcAft>
-                <a:spcPts val="1300"/>
-              </a:spcAft>
-            </a:pPr>
-            <a:r>
-              <a:rPr sz="1700" b="1">
+            <a:pPr algn="ctr">
+              <a:lnSpc>
+                <a:spcPct val="115000"/>
+              </a:lnSpc>
+              <a:spcAft>
+                <a:spcPts val="0"/>
+              </a:spcAft>
+            </a:pPr>
+            <a:r>
+              <a:rPr sz="1200" b="0">
                 <a:solidFill>
                   <a:srgbClr val="2563EB"/>
                 </a:solidFill>
                 <a:latin typeface="Segoe UI"/>
               </a:rPr>
-              <a:t>▪  </a:t>
-            </a:r>
-            <a:r>
-              <a:rPr sz="1700" b="1">
-                <a:solidFill>
-                  <a:srgbClr val="111827"/>
-                </a:solidFill>
-                <a:latin typeface="Segoe UI"/>
-              </a:rPr>
-              <a:t>Where:  </a:t>
-            </a:r>
-            <a:r>
-              <a:rPr sz="1700" b="0">
-                <a:solidFill>
-                  <a:srgbClr val="374151"/>
-                </a:solidFill>
-                <a:latin typeface="Segoe UI"/>
-              </a:rPr>
-              <a:t>served by GitHub Pages from docs/index.html — a single self-contained file with no build step and no server.</a:t>
-            </a:r>
-          </a:p>
-          <a:p>
-            <a:pPr algn="l">
-              <a:lnSpc>
-                <a:spcPct val="115000"/>
-              </a:lnSpc>
-              <a:spcAft>
-                <a:spcPts val="1300"/>
-              </a:spcAft>
-            </a:pPr>
-            <a:r>
-              <a:rPr sz="1700" b="1">
-                <a:solidFill>
-                  <a:srgbClr val="2563EB"/>
-                </a:solidFill>
-                <a:latin typeface="Segoe UI"/>
-              </a:rPr>
-              <a:t>▪  </a:t>
-            </a:r>
-            <a:r>
-              <a:rPr sz="1700" b="1">
-                <a:solidFill>
-                  <a:srgbClr val="111827"/>
-                </a:solidFill>
-                <a:latin typeface="Segoe UI"/>
-              </a:rPr>
-              <a:t>What it shows:  </a:t>
-            </a:r>
-            <a:r>
-              <a:rPr sz="1700" b="0">
-                <a:solidFill>
-                  <a:srgbClr val="374151"/>
-                </a:solidFill>
-                <a:latin typeface="Segoe UI"/>
-              </a:rPr>
-              <a:t>current state, every gate's history, releases blocked, and a plain-language verdict of whether the release was blocked and why.</a:t>
-            </a:r>
-          </a:p>
-          <a:p>
-            <a:pPr algn="l">
-              <a:lnSpc>
-                <a:spcPct val="115000"/>
-              </a:lnSpc>
-              <a:spcAft>
-                <a:spcPts val="1300"/>
-              </a:spcAft>
-            </a:pPr>
-            <a:r>
-              <a:rPr sz="1700" b="1">
-                <a:solidFill>
-                  <a:srgbClr val="2563EB"/>
-                </a:solidFill>
-                <a:latin typeface="Segoe UI"/>
-              </a:rPr>
-              <a:t>▪  </a:t>
-            </a:r>
-            <a:r>
-              <a:rPr sz="1700" b="1">
-                <a:solidFill>
-                  <a:srgbClr val="111827"/>
-                </a:solidFill>
-                <a:latin typeface="Segoe UI"/>
-              </a:rPr>
-              <a:t>Interactive:  </a:t>
-            </a:r>
-            <a:r>
-              <a:rPr sz="1700" b="0">
-                <a:solidFill>
-                  <a:srgbClr val="374151"/>
-                </a:solidFill>
-                <a:latin typeface="Segoe UI"/>
-              </a:rPr>
-              <a:t>click any stage for what it checks and how to run it locally; click any run to expand every job with durations and a link to its log.</a:t>
-            </a:r>
-          </a:p>
-          <a:p>
-            <a:pPr algn="l">
-              <a:lnSpc>
-                <a:spcPct val="115000"/>
-              </a:lnSpc>
-              <a:spcAft>
-                <a:spcPts val="1300"/>
-              </a:spcAft>
-            </a:pPr>
-            <a:r>
-              <a:rPr sz="1700" b="1">
-                <a:solidFill>
-                  <a:srgbClr val="2563EB"/>
-                </a:solidFill>
-                <a:latin typeface="Segoe UI"/>
-              </a:rPr>
-              <a:t>▪  </a:t>
-            </a:r>
-            <a:r>
-              <a:rPr sz="1700" b="1">
-                <a:solidFill>
-                  <a:srgbClr val="111827"/>
-                </a:solidFill>
-                <a:latin typeface="Segoe UI"/>
-              </a:rPr>
-              <a:t>Why it exists:  </a:t>
-            </a:r>
-            <a:r>
-              <a:rPr sz="1700" b="0">
-                <a:solidFill>
-                  <a:srgbClr val="374151"/>
-                </a:solidFill>
-                <a:latin typeface="Segoe UI"/>
-              </a:rPr>
-              <a:t>a manager should not need to read YAML to answer "are we safe to ship today?"</a:t>
-            </a:r>
-          </a:p>
-        </p:txBody>
-      </p:sp>
-      <p:sp>
-        <p:nvSpPr>
-          <p:cNvPr id="6" name="Rounded Rectangle 5"/>
+              <a:t>https://venkatvellapalem.github.io/DevSecOps/</a:t>
+            </a:r>
+          </a:p>
+        </p:txBody>
+      </p:sp>
+      <p:sp>
+        <p:nvSpPr>
+          <p:cNvPr id="7" name="Rounded Rectangle 6"/>
           <p:cNvSpPr/>
           <p:nvPr/>
         </p:nvSpPr>
         <p:spPr>
           <a:xfrm>
-            <a:off x="685800" y="4709160"/>
-            <a:ext cx="10817352" cy="1234440"/>
+            <a:off x="8366760" y="1627632"/>
+            <a:ext cx="3255264" cy="4407408"/>
           </a:xfrm>
           <a:prstGeom prst="roundRect">
             <a:avLst/>
@@ -7421,14 +7316,14 @@
       </p:sp>
       <p:sp>
         <p:nvSpPr>
-          <p:cNvPr id="7" name="TextBox 6"/>
+          <p:cNvPr id="8" name="TextBox 7"/>
           <p:cNvSpPr txBox="1"/>
           <p:nvPr/>
         </p:nvSpPr>
         <p:spPr>
           <a:xfrm>
-            <a:off x="960120" y="4837176"/>
-            <a:ext cx="10241280" cy="1005840"/>
+            <a:off x="8567928" y="1828800"/>
+            <a:ext cx="2852928" cy="4023360"/>
           </a:xfrm>
           <a:prstGeom prst="rect">
             <a:avLst/>
@@ -7446,43 +7341,157 @@
                 <a:spcPct val="115000"/>
               </a:lnSpc>
               <a:spcAft>
-                <a:spcPts val="300"/>
-              </a:spcAft>
-            </a:pPr>
-            <a:r>
-              <a:rPr sz="1200" b="1">
+                <a:spcPts val="700"/>
+              </a:spcAft>
+            </a:pPr>
+            <a:r>
+              <a:rPr sz="1150" b="1">
                 <a:solidFill>
                   <a:srgbClr val="2563EB"/>
                 </a:solidFill>
                 <a:latin typeface="Segoe UI"/>
               </a:rPr>
-              <a:t>DEMO IT LIVE</a:t>
-            </a:r>
-          </a:p>
-          <a:p>
-            <a:pPr algn="l">
-              <a:lnSpc>
-                <a:spcPct val="115000"/>
-              </a:lnSpc>
-              <a:spcAft>
-                <a:spcPts val="300"/>
-              </a:spcAft>
-            </a:pPr>
-            <a:r>
-              <a:rPr sz="1600" b="0">
+              <a:t>What you are looking at</a:t>
+            </a:r>
+          </a:p>
+          <a:p>
+            <a:pPr algn="l">
+              <a:lnSpc>
+                <a:spcPct val="115000"/>
+              </a:lnSpc>
+              <a:spcAft>
+                <a:spcPts val="700"/>
+              </a:spcAft>
+            </a:pPr>
+            <a:r>
+              <a:rPr sz="1150" b="0">
                 <a:solidFill>
                   <a:srgbClr val="374151"/>
                 </a:solidFill>
                 <a:latin typeface="Segoe UI"/>
               </a:rPr>
-              <a:t>https://venkatvellapalem.github.io/DevSecOps/</a:t>
-            </a:r>
-          </a:p>
-        </p:txBody>
-      </p:sp>
-      <p:sp>
-        <p:nvSpPr>
-          <p:cNvPr id="8" name="TextBox 7"/>
+              <a:t>One self-contained HTML file. No framework, no build step, no server to run.</a:t>
+            </a:r>
+          </a:p>
+          <a:p>
+            <a:pPr algn="l">
+              <a:lnSpc>
+                <a:spcPct val="115000"/>
+              </a:lnSpc>
+              <a:spcAft>
+                <a:spcPts val="700"/>
+              </a:spcAft>
+            </a:pPr>
+            <a:r>
+              <a:rPr sz="1150" b="1">
+                <a:solidFill>
+                  <a:srgbClr val="2563EB"/>
+                </a:solidFill>
+                <a:latin typeface="Segoe UI"/>
+              </a:rPr>
+              <a:t>Live</a:t>
+            </a:r>
+          </a:p>
+          <a:p>
+            <a:pPr algn="l">
+              <a:lnSpc>
+                <a:spcPct val="115000"/>
+              </a:lnSpc>
+              <a:spcAft>
+                <a:spcPts val="700"/>
+              </a:spcAft>
+            </a:pPr>
+            <a:r>
+              <a:rPr sz="1150" b="0">
+                <a:solidFill>
+                  <a:srgbClr val="374151"/>
+                </a:solidFill>
+                <a:latin typeface="Segoe UI"/>
+              </a:rPr>
+              <a:t>Reads the public GitHub API. The numbers are real, not a mockup.</a:t>
+            </a:r>
+          </a:p>
+          <a:p>
+            <a:pPr algn="l">
+              <a:lnSpc>
+                <a:spcPct val="115000"/>
+              </a:lnSpc>
+              <a:spcAft>
+                <a:spcPts val="700"/>
+              </a:spcAft>
+            </a:pPr>
+            <a:r>
+              <a:rPr sz="1150" b="1">
+                <a:solidFill>
+                  <a:srgbClr val="2563EB"/>
+                </a:solidFill>
+                <a:latin typeface="Segoe UI"/>
+              </a:rPr>
+              <a:t>Interactive</a:t>
+            </a:r>
+          </a:p>
+          <a:p>
+            <a:pPr algn="l">
+              <a:lnSpc>
+                <a:spcPct val="115000"/>
+              </a:lnSpc>
+              <a:spcAft>
+                <a:spcPts val="700"/>
+              </a:spcAft>
+            </a:pPr>
+            <a:r>
+              <a:rPr sz="1150" b="0">
+                <a:solidFill>
+                  <a:srgbClr val="374151"/>
+                </a:solidFill>
+                <a:latin typeface="Segoe UI"/>
+              </a:rPr>
+              <a:t>Click any stage for what it checks. Click any run to expand every job.</a:t>
+            </a:r>
+          </a:p>
+          <a:p>
+            <a:pPr algn="l">
+              <a:lnSpc>
+                <a:spcPct val="115000"/>
+              </a:lnSpc>
+              <a:spcAft>
+                <a:spcPts val="700"/>
+              </a:spcAft>
+            </a:pPr>
+            <a:r>
+              <a:rPr sz="1150" b="1">
+                <a:solidFill>
+                  <a:srgbClr val="2563EB"/>
+                </a:solidFill>
+                <a:latin typeface="Segoe UI"/>
+              </a:rPr>
+              <a:t>Why it exists</a:t>
+            </a:r>
+          </a:p>
+          <a:p>
+            <a:pPr algn="l">
+              <a:lnSpc>
+                <a:spcPct val="115000"/>
+              </a:lnSpc>
+              <a:spcAft>
+                <a:spcPts val="700"/>
+              </a:spcAft>
+            </a:pPr>
+            <a:r>
+              <a:rPr sz="1150" b="0">
+                <a:solidFill>
+                  <a:srgbClr val="374151"/>
+                </a:solidFill>
+                <a:latin typeface="Segoe UI"/>
+              </a:rPr>
+              <a:t>A manager should not need to read YAML to answer: are we safe to ship today?</a:t>
+            </a:r>
+          </a:p>
+        </p:txBody>
+      </p:sp>
+      <p:sp>
+        <p:nvSpPr>
+          <p:cNvPr id="9" name="TextBox 8"/>
           <p:cNvSpPr txBox="1"/>
           <p:nvPr/>
         </p:nvSpPr>

</xml_diff>

<commit_message>
Deck: fix off-by-one slide numbering
nxt() only advanced on content slides, so slide 2 was labelled 1 and the closing
slide carried no number at all. The counter now advances on every slide while the
title and closing slides still simply do not render one.
</commit_message>
<xml_diff>
--- a/deliverables/DevSecOps_Secure_Pipeline.pptx
+++ b/deliverables/DevSecOps_Secure_Pipeline.pptx
@@ -5483,7 +5483,7 @@
                 </a:solidFill>
                 <a:latin typeface="Segoe UI"/>
               </a:rPr>
-              <a:t>9</a:t>
+              <a:t>10</a:t>
             </a:r>
           </a:p>
         </p:txBody>
@@ -5949,7 +5949,7 @@
                 </a:solidFill>
                 <a:latin typeface="Segoe UI"/>
               </a:rPr>
-              <a:t>10</a:t>
+              <a:t>11</a:t>
             </a:r>
           </a:p>
         </p:txBody>
@@ -6161,7 +6161,7 @@
                 </a:solidFill>
                 <a:latin typeface="Segoe UI"/>
               </a:rPr>
-              <a:t>11</a:t>
+              <a:t>12</a:t>
             </a:r>
           </a:p>
         </p:txBody>
@@ -6373,7 +6373,7 @@
                 </a:solidFill>
                 <a:latin typeface="Segoe UI"/>
               </a:rPr>
-              <a:t>12</a:t>
+              <a:t>13</a:t>
             </a:r>
           </a:p>
         </p:txBody>
@@ -6839,7 +6839,7 @@
                 </a:solidFill>
                 <a:latin typeface="Segoe UI"/>
               </a:rPr>
-              <a:t>13</a:t>
+              <a:t>14</a:t>
             </a:r>
           </a:p>
         </p:txBody>
@@ -7051,7 +7051,7 @@
                 </a:solidFill>
                 <a:latin typeface="Segoe UI"/>
               </a:rPr>
-              <a:t>14</a:t>
+              <a:t>15</a:t>
             </a:r>
           </a:p>
         </p:txBody>
@@ -7526,7 +7526,7 @@
                 </a:solidFill>
                 <a:latin typeface="Segoe UI"/>
               </a:rPr>
-              <a:t>15</a:t>
+              <a:t>16</a:t>
             </a:r>
           </a:p>
         </p:txBody>
@@ -7992,7 +7992,7 @@
                 </a:solidFill>
                 <a:latin typeface="Segoe UI"/>
               </a:rPr>
-              <a:t>16</a:t>
+              <a:t>17</a:t>
             </a:r>
           </a:p>
         </p:txBody>
@@ -8458,7 +8458,7 @@
                 </a:solidFill>
                 <a:latin typeface="Segoe UI"/>
               </a:rPr>
-              <a:t>17</a:t>
+              <a:t>18</a:t>
             </a:r>
           </a:p>
         </p:txBody>
@@ -8924,7 +8924,7 @@
                 </a:solidFill>
                 <a:latin typeface="Segoe UI"/>
               </a:rPr>
-              <a:t>18</a:t>
+              <a:t>19</a:t>
             </a:r>
           </a:p>
         </p:txBody>
@@ -9390,7 +9390,7 @@
                 </a:solidFill>
                 <a:latin typeface="Segoe UI"/>
               </a:rPr>
-              <a:t>1</a:t>
+              <a:t>2</a:t>
             </a:r>
           </a:p>
         </p:txBody>
@@ -9963,7 +9963,7 @@
                 </a:solidFill>
                 <a:latin typeface="Segoe UI"/>
               </a:rPr>
-              <a:t>19</a:t>
+              <a:t>20</a:t>
             </a:r>
           </a:p>
         </p:txBody>
@@ -10482,7 +10482,7 @@
                 </a:solidFill>
                 <a:latin typeface="Segoe UI"/>
               </a:rPr>
-              <a:t>20</a:t>
+              <a:t>21</a:t>
             </a:r>
           </a:p>
         </p:txBody>
@@ -11134,7 +11134,7 @@
                 </a:solidFill>
                 <a:latin typeface="Segoe UI"/>
               </a:rPr>
-              <a:t>2</a:t>
+              <a:t>3</a:t>
             </a:r>
           </a:p>
         </p:txBody>
@@ -11346,7 +11346,7 @@
                 </a:solidFill>
                 <a:latin typeface="Segoe UI"/>
               </a:rPr>
-              <a:t>3</a:t>
+              <a:t>4</a:t>
             </a:r>
           </a:p>
         </p:txBody>
@@ -11812,7 +11812,7 @@
                 </a:solidFill>
                 <a:latin typeface="Segoe UI"/>
               </a:rPr>
-              <a:t>4</a:t>
+              <a:t>5</a:t>
             </a:r>
           </a:p>
         </p:txBody>
@@ -12278,7 +12278,7 @@
                 </a:solidFill>
                 <a:latin typeface="Segoe UI"/>
               </a:rPr>
-              <a:t>5</a:t>
+              <a:t>6</a:t>
             </a:r>
           </a:p>
         </p:txBody>
@@ -12744,7 +12744,7 @@
                 </a:solidFill>
                 <a:latin typeface="Segoe UI"/>
               </a:rPr>
-              <a:t>6</a:t>
+              <a:t>7</a:t>
             </a:r>
           </a:p>
         </p:txBody>
@@ -13210,7 +13210,7 @@
                 </a:solidFill>
                 <a:latin typeface="Segoe UI"/>
               </a:rPr>
-              <a:t>7</a:t>
+              <a:t>8</a:t>
             </a:r>
           </a:p>
         </p:txBody>
@@ -13676,7 +13676,7 @@
                 </a:solidFill>
                 <a:latin typeface="Segoe UI"/>
               </a:rPr>
-              <a:t>8</a:t>
+              <a:t>9</a:t>
             </a:r>
           </a:p>
         </p:txBody>

</xml_diff>